<commit_message>
fix: factual correctness of presentation
</commit_message>
<xml_diff>
--- a/presentation.pptx
+++ b/presentation.pptx
@@ -1309,7 +1309,7 @@
           <a:p>
             <a:r>
               <a:rPr lang="en-US" dirty="0"/>
-              <a:t>Let me walk you through the app. At its core, Förseningskartan is a map-based interface. Every dot on the map is a transit stop point — colour-coded by mode: blue for metro, red for bus, green for tram, and so on. You can filter which modes to show, and even hide stops that currently have no departures. Clicking a stop opens a live departure panel showing upcoming arrivals with their delays. You can search and filter within the departure list, and you can favorite stops for quick access. But the real differentiator is the historical view. You can navigate to the route delay page to see how delayed a specific route has been historically — with both a leaderboard of the most delayed routes and a trend chart showing delays by day or by hour. The app supports three colour themes, two languages, user accounts with Google sign-in, and persisted preferences. It's also mobile-responsive.</a:t>
+              <a:t>Let me walk you through the app. At its core, Förseningskartan is a map-based interface. Every dot on the map is a transit stop point. You can filter which modes to show on the map, and even hide stops that currently have no departures. The stop markers automatically adapt their style to match your active theme, and when you select a route, all stops on that route are highlighted in bright orange so you can trace it visually. The selected stop itself highlights in red. Clicking a stop opens a live departure panel showing upcoming arrivals with their delays. You can search and filter within the departure list, and you can favorite stops for quick access. But the real differentiator is the historical view. You can navigate to the route delay page to see how delayed a specific route has been historically — with both a leaderboard of the most delayed routes and a trend chart showing delays by day or by hour. The app supports three colour themes, two languages, user accounts with Google sign-in, and persisted preferences. It's also mobile-responsive.</a:t>
             </a:r>
             <a:endParaRPr lang="en-US" dirty="0"/>
           </a:p>
@@ -1573,7 +1573,7 @@
           <a:p>
             <a:r>
               <a:rPr lang="en-US" dirty="0"/>
-              <a:t>The map-first design was a deliberate UX choice. When you're wondering about delays, you think spatially — 'what's around me?' — not in terms of route numbers. So the map is the primary navigation tool. The search bar overlays the map rather than living on a separate page, which keeps the spatial context. Your recent searches are remembered and shown as suggestions. We also added a geolocation button so you can instantly centre the map on your location. Stop markers are colour-coded by transport mode, and you can filter by mode or hide stops with no departures — something users explicitly asked for. This reduces visual noise. We use progressive disclosure: the map → clicking a stop → the departure panel → and from there a button takes you to detailed route delay statistics. Each step reveals more detail without overwhelming the user upfront.</a:t>
+              <a:t>The map-first design was a deliberate UX choice. When you're wondering about delays, you think spatially — 'what's around me?' — not in terms of route numbers. So the map is the primary navigation tool. The search bar overlays the map rather than living on a separate page, which keeps the spatial context. Your recent searches are remembered and shown as suggestions. We also added a geolocation button so you can instantly centre the map on your location. Stop markers are styled to match the active theme. To keep the map clean and prevent noise, we allow users to filter stops by transport mode or hide stops with no active departures. When a route is highlighted, we trace all its stops in orange, and highlight the selected stop in red. We use progressive disclosure: the map → clicking a stop → the departure panel → and from there a button takes you to detailed route delay statistics. Each step reveals more detail without overwhelming the user upfront.</a:t>
             </a:r>
             <a:endParaRPr lang="en-US" dirty="0"/>
           </a:p>
@@ -1837,7 +1837,7 @@
           <a:p>
             <a:r>
               <a:rPr lang="en-US" dirty="0"/>
-              <a:t>We built three full colour themes — light, dark, and a blue accent mode — using Material UI's theming system. Each theme is defined as a complete MUI theme object, so every component in the app respects the chosen palette consistently. We also implemented full Swedish and English translations. This is important for a Stockholm-focused app where the user base is bilingual. The language preference is of course persisted. These might seem like 'nice-to-haves', but in a UX prize context, they signal attention to detail and respect for user preferences.</a:t>
+              <a:t>We built three full colour themes — Light, Dark, and a Classic Sepia/Cream mode — using Material UI's theming system. Each theme is defined as a complete MUI theme object, so every component in the app respects the chosen palette consistently. We also implemented full Swedish and English translations. This is important for a Stockholm-focused app where the user base is bilingual. The language preference is of course persisted. These might seem like 'nice-to-haves', but in a UX prize context, they signal attention to detail and respect for user preferences.</a:t>
             </a:r>
             <a:endParaRPr lang="en-US" dirty="0"/>
           </a:p>
@@ -2871,7 +2871,7 @@
                 <a:ea typeface="Calibri" pitchFamily="34" charset="-122"/>
                 <a:cs typeface="Calibri" pitchFamily="34" charset="-120"/>
               </a:rPr>
-              <a:t>Daily Go script</a:t>
+              <a:t>Daily Go daemon</a:t>
             </a:r>
             <a:endParaRPr lang="en-US" sz="1100" dirty="0"/>
           </a:p>
@@ -3282,7 +3282,7 @@
                 <a:ea typeface="Calibri" pitchFamily="34" charset="-122"/>
                 <a:cs typeface="Calibri" pitchFamily="34" charset="-120"/>
               </a:rPr>
-              <a:t>Leaflet &amp; Recharts</a:t>
+              <a:t>Leaflet &amp; MUI X Charts</a:t>
             </a:r>
             <a:endParaRPr lang="en-US" sz="1100" dirty="0"/>
           </a:p>
@@ -9270,7 +9270,7 @@
                 <a:ea typeface="Calibri" pitchFamily="34" charset="-122"/>
                 <a:cs typeface="Calibri" pitchFamily="34" charset="-120"/>
               </a:rPr>
-              <a:t>Stop markers color-coded by mode (Metro, Bus, Tram, Train).</a:t>
+              <a:t>Smart highlighting: selected stops in red, active route in orange.</a:t>
             </a:r>
             <a:endParaRPr lang="en-US" sz="1200" dirty="0"/>
           </a:p>
@@ -10889,7 +10889,7 @@
                 <a:ea typeface="Calibri" pitchFamily="34" charset="-122"/>
                 <a:cs typeface="Calibri" pitchFamily="34" charset="-120"/>
               </a:rPr>
-              <a:t>React + TS + Vite, MUI components, Leaflet maps, Redux Toolkit for state management.
+              <a:t>React + TS + Vite, MUI components, Tailwind CSS, Leaflet maps, Redux Toolkit.
 </a:t>
             </a:r>
             <a:endParaRPr lang="en-US" sz="1100" dirty="0"/>
@@ -10927,7 +10927,7 @@
                 <a:ea typeface="Calibri" pitchFamily="34" charset="-122"/>
                 <a:cs typeface="Calibri" pitchFamily="34" charset="-120"/>
               </a:rPr>
-              <a:t>Go HTTP Server (REST API) + Go Protobuf parsing engine running daily as a systemd-timer.
+              <a:t>Go REST API &amp; Protobuf aggregator with internal cron scheduler, exposing Prometheus metrics.
 </a:t>
             </a:r>
             <a:endParaRPr lang="en-US" sz="1100" dirty="0"/>
@@ -10965,7 +10965,7 @@
                 <a:ea typeface="Calibri" pitchFamily="34" charset="-122"/>
                 <a:cs typeface="Calibri" pitchFamily="34" charset="-120"/>
               </a:rPr>
-              <a:t>PostgreSQL 16 relational database hosted on a VPS.
+              <a:t>PostgreSQL 16 relational database (Dockerized).
 </a:t>
             </a:r>
             <a:endParaRPr lang="en-US" sz="1100" dirty="0"/>
@@ -11003,7 +11003,7 @@
                 <a:ea typeface="Calibri" pitchFamily="34" charset="-122"/>
                 <a:cs typeface="Calibri" pitchFamily="34" charset="-120"/>
               </a:rPr>
-              <a:t>Firebase Auth + cloud Firestore listeners for instant preference sync.</a:t>
+              <a:t>Firebase Auth + cloud Firestore listeners for preference sync.</a:t>
             </a:r>
             <a:endParaRPr lang="en-US" sz="1100" dirty="0"/>
           </a:p>
@@ -12597,7 +12597,7 @@
                 <a:ea typeface="Calibri" pitchFamily="34" charset="-122"/>
                 <a:cs typeface="Calibri" pitchFamily="34" charset="-120"/>
               </a:rPr>
-              <a:t>Commuters think geographically. Showing delay markers on an interactive map gives instant neighborhood delay status without lists.</a:t>
+              <a:t>Commuters think geographically. Interactive map markers display transit stops, with selected/route highlights and responsive pan-and-zoom scaling.</a:t>
             </a:r>
             <a:endParaRPr lang="en-US" sz="1400" dirty="0"/>
           </a:p>
@@ -12650,7 +12650,7 @@
             <a:avLst/>
           </a:prstGeom>
           <a:solidFill>
-            <a:srgbClr val="DC2626"/>
+            <a:srgbClr val="028090"/>
           </a:solidFill>
           <a:ln w="12700">
             <a:solidFill>
@@ -12675,7 +12675,7 @@
             <a:avLst/>
           </a:prstGeom>
           <a:solidFill>
-            <a:srgbClr val="DC2626"/>
+            <a:srgbClr val="028090"/>
           </a:solidFill>
           <a:ln w="12700">
             <a:solidFill>
@@ -12736,7 +12736,7 @@
                 <a:ea typeface="Calibri" pitchFamily="34" charset="-122"/>
                 <a:cs typeface="Calibri" pitchFamily="34" charset="-120"/>
               </a:rPr>
-              <a:t>The search box overlays the map directly. Users search and see results without losing spatial context. Remembers recent history.</a:t>
+              <a:t>Floating search bar overlays the map directly, letting users search and see matches without losing geographical context. Remembers recent queries.</a:t>
             </a:r>
             <a:endParaRPr lang="en-US" sz="1400" dirty="0"/>
           </a:p>
@@ -12789,7 +12789,7 @@
             <a:avLst/>
           </a:prstGeom>
           <a:solidFill>
-            <a:srgbClr val="028090"/>
+            <a:srgbClr val="16A34A"/>
           </a:solidFill>
           <a:ln w="12700">
             <a:solidFill>
@@ -12814,7 +12814,7 @@
             <a:avLst/>
           </a:prstGeom>
           <a:solidFill>
-            <a:srgbClr val="028090"/>
+            <a:srgbClr val="16A34A"/>
           </a:solidFill>
           <a:ln w="12700">
             <a:solidFill>
@@ -12875,7 +12875,7 @@
                 <a:ea typeface="Calibri" pitchFamily="34" charset="-122"/>
                 <a:cs typeface="Calibri" pitchFamily="34" charset="-120"/>
               </a:rPr>
-              <a:t>A dedicated geolocation floating button automatically pans the map to the user's current physical coordinates for immediate nearby stops.</a:t>
+              <a:t>Floating action button uses browser geolocation to instantly center the map on the user's current coordinates to show nearby transit stops.</a:t>
             </a:r>
             <a:endParaRPr lang="en-US" sz="1400" dirty="0"/>
           </a:p>
@@ -12928,7 +12928,7 @@
             <a:avLst/>
           </a:prstGeom>
           <a:solidFill>
-            <a:srgbClr val="16A34A"/>
+            <a:srgbClr val="DC2626"/>
           </a:solidFill>
           <a:ln w="12700">
             <a:solidFill>
@@ -12953,7 +12953,7 @@
             <a:avLst/>
           </a:prstGeom>
           <a:solidFill>
-            <a:srgbClr val="16A34A"/>
+            <a:srgbClr val="DC2626"/>
           </a:solidFill>
           <a:ln w="12700">
             <a:solidFill>
@@ -13014,7 +13014,7 @@
                 <a:ea typeface="Calibri" pitchFamily="34" charset="-122"/>
                 <a:cs typeface="Calibri" pitchFamily="34" charset="-120"/>
               </a:rPr>
-              <a:t>Clean map layout hides noisy stop markers. User clicks a stop -&gt; views live departures -&gt; taps a line -&gt; inspects historical trends.</a:t>
+              <a:t>Reduces visual clutter: users click a map stop -&gt; view departures -&gt; click a route -&gt; view detailed leaderboards and historical trend charts.</a:t>
             </a:r>
             <a:endParaRPr lang="en-US" sz="1400" dirty="0"/>
           </a:p>
@@ -14676,7 +14676,7 @@
             <a:avLst/>
           </a:prstGeom>
           <a:solidFill>
-            <a:srgbClr val="0D9488"/>
+            <a:srgbClr val="2563EB"/>
           </a:solidFill>
           <a:ln w="12700">
             <a:solidFill>
@@ -14713,7 +14713,7 @@
             <a:r>
               <a:rPr lang="en-US" sz="1600" b="1" dirty="0">
                 <a:solidFill>
-                  <a:srgbClr val="1E293B"/>
+                  <a:srgbClr val="0F172A"/>
                 </a:solidFill>
                 <a:latin typeface="Trebuchet MS" pitchFamily="34" charset="0"/>
                 <a:ea typeface="Trebuchet MS" pitchFamily="34" charset="-122"/>
@@ -14749,7 +14749,7 @@
             <a:r>
               <a:rPr lang="en-US" sz="1000" b="1" dirty="0">
                 <a:solidFill>
-                  <a:srgbClr val="0D9488"/>
+                  <a:srgbClr val="2563EB"/>
                 </a:solidFill>
                 <a:latin typeface="Calibri" pitchFamily="34" charset="0"/>
                 <a:ea typeface="Calibri" pitchFamily="34" charset="-122"/>
@@ -14808,7 +14808,7 @@
             <a:avLst/>
           </a:prstGeom>
           <a:solidFill>
-            <a:srgbClr val="38BDF8"/>
+            <a:srgbClr val="60A5FA"/>
           </a:solidFill>
           <a:ln w="12700">
             <a:solidFill>
@@ -14845,7 +14845,7 @@
             <a:r>
               <a:rPr lang="en-US" sz="1600" b="1" dirty="0">
                 <a:solidFill>
-                  <a:srgbClr val="F8FAFC"/>
+                  <a:srgbClr val="FFFFFF"/>
                 </a:solidFill>
                 <a:latin typeface="Trebuchet MS" pitchFamily="34" charset="0"/>
                 <a:ea typeface="Trebuchet MS" pitchFamily="34" charset="-122"/>
@@ -14881,7 +14881,7 @@
             <a:r>
               <a:rPr lang="en-US" sz="1000" b="1" dirty="0">
                 <a:solidFill>
-                  <a:srgbClr val="F8FAFC"/>
+                  <a:srgbClr val="60A5FA"/>
                 </a:solidFill>
                 <a:latin typeface="Calibri" pitchFamily="34" charset="0"/>
                 <a:ea typeface="Calibri" pitchFamily="34" charset="-122"/>
@@ -14908,7 +14908,7 @@
             <a:avLst/>
           </a:prstGeom>
           <a:solidFill>
-            <a:srgbClr val="1E3A8A"/>
+            <a:srgbClr val="F7F0DF"/>
           </a:solidFill>
           <a:ln w="12700">
             <a:solidFill>
@@ -14940,7 +14940,7 @@
             <a:avLst/>
           </a:prstGeom>
           <a:solidFill>
-            <a:srgbClr val="FBBF24"/>
+            <a:srgbClr val="8B5E3B"/>
           </a:solidFill>
           <a:ln w="12700">
             <a:solidFill>
@@ -14977,13 +14977,13 @@
             <a:r>
               <a:rPr lang="en-US" sz="1600" b="1" dirty="0">
                 <a:solidFill>
-                  <a:srgbClr val="FFFFFF"/>
+                  <a:srgbClr val="3F2F1F"/>
                 </a:solidFill>
                 <a:latin typeface="Trebuchet MS" pitchFamily="34" charset="0"/>
                 <a:ea typeface="Trebuchet MS" pitchFamily="34" charset="-122"/>
                 <a:cs typeface="Trebuchet MS" pitchFamily="34" charset="-120"/>
               </a:rPr>
-              <a:t>Transit Blue Theme
+              <a:t>Classic Theme
 </a:t>
             </a:r>
             <a:endParaRPr lang="en-US" sz="1600" dirty="0"/>
@@ -14995,13 +14995,13 @@
             <a:r>
               <a:rPr lang="en-US" sz="1100" i="1" dirty="0">
                 <a:solidFill>
-                  <a:srgbClr val="94A3B8"/>
-                </a:solidFill>
-                <a:latin typeface="Calibri" pitchFamily="34" charset="0"/>
-                <a:ea typeface="Calibri" pitchFamily="34" charset="-122"/>
-                <a:cs typeface="Calibri" pitchFamily="34" charset="-120"/>
-              </a:rPr>
-              <a:t>SL Stockholm branding
+                  <a:srgbClr val="475569"/>
+                </a:solidFill>
+                <a:latin typeface="Calibri" pitchFamily="34" charset="0"/>
+                <a:ea typeface="Calibri" pitchFamily="34" charset="-122"/>
+                <a:cs typeface="Calibri" pitchFamily="34" charset="-120"/>
+              </a:rPr>
+              <a:t>Warm sepia/cream retro style
 </a:t>
             </a:r>
             <a:endParaRPr lang="en-US" sz="1600" dirty="0"/>
@@ -15013,7 +15013,7 @@
             <a:r>
               <a:rPr lang="en-US" sz="1000" b="1" dirty="0">
                 <a:solidFill>
-                  <a:srgbClr val="FBBF24"/>
+                  <a:srgbClr val="8B5E3B"/>
                 </a:solidFill>
                 <a:latin typeface="Calibri" pitchFamily="34" charset="0"/>
                 <a:ea typeface="Calibri" pitchFamily="34" charset="-122"/>

</xml_diff>